<commit_message>
Workshop 03, vectorstore, TTS
</commit_message>
<xml_diff>
--- a/workshop/PRD2.2_ChromaDB_HFTTS_Explainer.pptx
+++ b/workshop/PRD2.2_ChromaDB_HFTTS_Explainer.pptx
@@ -3968,7 +3968,7 @@
                 <a:ea typeface="Cambria" pitchFamily="34" charset="-122"/>
                 <a:cs typeface="Cambria" pitchFamily="34" charset="-120"/>
               </a:rPr>
-              <a:t>Demo thật: 4 cảnh báo vào → 2 sự cố duy nhất</a:t>
+              <a:t>Demo thật: 5 cảnh báo vào → 3 sự cố duy nhất</a:t>
             </a:r>
             <a:endParaRPr lang="en-US" sz="3000" dirty="0"/>
           </a:p>
@@ -3982,8 +3982,8 @@
         </p:nvSpPr>
         <p:spPr>
           <a:xfrm>
-            <a:off x="685800" y="1783080"/>
-            <a:ext cx="5852160" cy="320040"/>
+            <a:off x="685800" y="1691640"/>
+            <a:ext cx="5852160" cy="292608"/>
           </a:xfrm>
           <a:prstGeom prst="rect">
             <a:avLst/>
@@ -4021,8 +4021,8 @@
         </p:nvSpPr>
         <p:spPr>
           <a:xfrm>
-            <a:off x="6675120" y="1783080"/>
-            <a:ext cx="4846320" cy="320040"/>
+            <a:off x="6675120" y="1691640"/>
+            <a:ext cx="4846320" cy="292608"/>
           </a:xfrm>
           <a:prstGeom prst="rect">
             <a:avLst/>
@@ -4060,12 +4060,12 @@
         </p:nvSpPr>
         <p:spPr>
           <a:xfrm>
-            <a:off x="548640" y="2148840"/>
-            <a:ext cx="5943600" cy="713232"/>
+            <a:off x="548640" y="2011680"/>
+            <a:ext cx="5943600" cy="576072"/>
           </a:xfrm>
           <a:prstGeom prst="roundRect">
             <a:avLst>
-              <a:gd name="adj" fmla="val 11538"/>
+              <a:gd name="adj" fmla="val 14286"/>
             </a:avLst>
           </a:prstGeom>
           <a:solidFill>
@@ -4094,24 +4094,24 @@
         </p:nvSpPr>
         <p:spPr>
           <a:xfrm>
-            <a:off x="731520" y="2148840"/>
-            <a:ext cx="5669280" cy="713232"/>
-          </a:xfrm>
-          <a:prstGeom prst="rect">
-            <a:avLst/>
-          </a:prstGeom>
-          <a:noFill/>
-          <a:ln/>
-        </p:spPr>
-        <p:txBody>
-          <a:bodyPr wrap="square" lIns="0" tIns="0" rIns="0" bIns="0" rtlCol="0" anchor="ctr"/>
-          <a:lstStyle/>
-          <a:p>
-            <a:pPr indent="0" marL="0">
-              <a:buNone/>
-            </a:pPr>
-            <a:r>
-              <a:rPr lang="en-US" sz="1250" dirty="0">
+            <a:off x="731520" y="2011680"/>
+            <a:ext cx="5669280" cy="576072"/>
+          </a:xfrm>
+          <a:prstGeom prst="rect">
+            <a:avLst/>
+          </a:prstGeom>
+          <a:noFill/>
+          <a:ln/>
+        </p:spPr>
+        <p:txBody>
+          <a:bodyPr wrap="square" lIns="0" tIns="0" rIns="0" bIns="0" rtlCol="0" anchor="ctr"/>
+          <a:lstStyle/>
+          <a:p>
+            <a:pPr indent="0" marL="0">
+              <a:buNone/>
+            </a:pPr>
+            <a:r>
+              <a:rPr lang="en-US" sz="1200" dirty="0">
                 <a:solidFill>
                   <a:srgbClr val="172033"/>
                 </a:solidFill>
@@ -4121,7 +4121,7 @@
               </a:rPr>
               <a:t>Payment declined #10293 — fraud</a:t>
             </a:r>
-            <a:endParaRPr lang="en-US" sz="1250" dirty="0"/>
+            <a:endParaRPr lang="en-US" sz="1200" dirty="0"/>
           </a:p>
         </p:txBody>
       </p:sp>
@@ -4133,12 +4133,12 @@
         </p:nvSpPr>
         <p:spPr>
           <a:xfrm>
-            <a:off x="6675120" y="2148840"/>
-            <a:ext cx="4983480" cy="713232"/>
+            <a:off x="6675120" y="2011680"/>
+            <a:ext cx="4983480" cy="576072"/>
           </a:xfrm>
           <a:prstGeom prst="roundRect">
             <a:avLst>
-              <a:gd name="adj" fmla="val 10256"/>
+              <a:gd name="adj" fmla="val 12698"/>
             </a:avLst>
           </a:prstGeom>
           <a:solidFill>
@@ -4160,24 +4160,24 @@
         </p:nvSpPr>
         <p:spPr>
           <a:xfrm>
-            <a:off x="6858000" y="2148840"/>
-            <a:ext cx="4663440" cy="713232"/>
-          </a:xfrm>
-          <a:prstGeom prst="rect">
-            <a:avLst/>
-          </a:prstGeom>
-          <a:noFill/>
-          <a:ln/>
-        </p:spPr>
-        <p:txBody>
-          <a:bodyPr wrap="square" lIns="0" tIns="0" rIns="0" bIns="0" rtlCol="0" anchor="ctr"/>
-          <a:lstStyle/>
-          <a:p>
-            <a:pPr indent="0" marL="0">
-              <a:buNone/>
-            </a:pPr>
-            <a:r>
-              <a:rPr lang="en-US" sz="1300" b="1" dirty="0">
+            <a:off x="6858000" y="2011680"/>
+            <a:ext cx="4663440" cy="576072"/>
+          </a:xfrm>
+          <a:prstGeom prst="rect">
+            <a:avLst/>
+          </a:prstGeom>
+          <a:noFill/>
+          <a:ln/>
+        </p:spPr>
+        <p:txBody>
+          <a:bodyPr wrap="square" lIns="0" tIns="0" rIns="0" bIns="0" rtlCol="0" anchor="ctr"/>
+          <a:lstStyle/>
+          <a:p>
+            <a:pPr indent="0" marL="0">
+              <a:buNone/>
+            </a:pPr>
+            <a:r>
+              <a:rPr lang="en-US" sz="1250" b="1" dirty="0">
                 <a:solidFill>
                   <a:srgbClr val="B06E00"/>
                 </a:solidFill>
@@ -4191,7 +4191,7 @@
               <a:buNone/>
             </a:pPr>
             <a:r>
-              <a:rPr lang="en-US" sz="1300" dirty="0">
+              <a:rPr lang="en-US" sz="1250" dirty="0">
                 <a:solidFill>
                   <a:srgbClr val="5A6474"/>
                 </a:solidFill>
@@ -4201,7 +4201,7 @@
               </a:rPr>
               <a:t>· xuất hiện lần 1</a:t>
             </a:r>
-            <a:endParaRPr lang="en-US" sz="1300" dirty="0"/>
+            <a:endParaRPr lang="en-US" sz="1250" dirty="0"/>
           </a:p>
         </p:txBody>
       </p:sp>
@@ -4213,12 +4213,12 @@
         </p:nvSpPr>
         <p:spPr>
           <a:xfrm>
-            <a:off x="548640" y="2990088"/>
-            <a:ext cx="5943600" cy="713232"/>
+            <a:off x="548640" y="2697480"/>
+            <a:ext cx="5943600" cy="576072"/>
           </a:xfrm>
           <a:prstGeom prst="roundRect">
             <a:avLst>
-              <a:gd name="adj" fmla="val 11538"/>
+              <a:gd name="adj" fmla="val 14286"/>
             </a:avLst>
           </a:prstGeom>
           <a:solidFill>
@@ -4247,24 +4247,24 @@
         </p:nvSpPr>
         <p:spPr>
           <a:xfrm>
-            <a:off x="731520" y="2990088"/>
-            <a:ext cx="5669280" cy="713232"/>
-          </a:xfrm>
-          <a:prstGeom prst="rect">
-            <a:avLst/>
-          </a:prstGeom>
-          <a:noFill/>
-          <a:ln/>
-        </p:spPr>
-        <p:txBody>
-          <a:bodyPr wrap="square" lIns="0" tIns="0" rIns="0" bIns="0" rtlCol="0" anchor="ctr"/>
-          <a:lstStyle/>
-          <a:p>
-            <a:pPr indent="0" marL="0">
-              <a:buNone/>
-            </a:pPr>
-            <a:r>
-              <a:rPr lang="en-US" sz="1250" dirty="0">
+            <a:off x="731520" y="2697480"/>
+            <a:ext cx="5669280" cy="576072"/>
+          </a:xfrm>
+          <a:prstGeom prst="rect">
+            <a:avLst/>
+          </a:prstGeom>
+          <a:noFill/>
+          <a:ln/>
+        </p:spPr>
+        <p:txBody>
+          <a:bodyPr wrap="square" lIns="0" tIns="0" rIns="0" bIns="0" rtlCol="0" anchor="ctr"/>
+          <a:lstStyle/>
+          <a:p>
+            <a:pPr indent="0" marL="0">
+              <a:buNone/>
+            </a:pPr>
+            <a:r>
+              <a:rPr lang="en-US" sz="1200" dirty="0">
                 <a:solidFill>
                   <a:srgbClr val="172033"/>
                 </a:solidFill>
@@ -4274,7 +4274,7 @@
               </a:rPr>
               <a:t>Payment declined #55019 — fraud suspected</a:t>
             </a:r>
-            <a:endParaRPr lang="en-US" sz="1250" dirty="0"/>
+            <a:endParaRPr lang="en-US" sz="1200" dirty="0"/>
           </a:p>
         </p:txBody>
       </p:sp>
@@ -4286,12 +4286,12 @@
         </p:nvSpPr>
         <p:spPr>
           <a:xfrm>
-            <a:off x="6675120" y="2990088"/>
-            <a:ext cx="4983480" cy="713232"/>
+            <a:off x="6675120" y="2697480"/>
+            <a:ext cx="4983480" cy="576072"/>
           </a:xfrm>
           <a:prstGeom prst="roundRect">
             <a:avLst>
-              <a:gd name="adj" fmla="val 10256"/>
+              <a:gd name="adj" fmla="val 12698"/>
             </a:avLst>
           </a:prstGeom>
           <a:solidFill>
@@ -4313,24 +4313,24 @@
         </p:nvSpPr>
         <p:spPr>
           <a:xfrm>
-            <a:off x="6858000" y="2990088"/>
-            <a:ext cx="4663440" cy="713232"/>
-          </a:xfrm>
-          <a:prstGeom prst="rect">
-            <a:avLst/>
-          </a:prstGeom>
-          <a:noFill/>
-          <a:ln/>
-        </p:spPr>
-        <p:txBody>
-          <a:bodyPr wrap="square" lIns="0" tIns="0" rIns="0" bIns="0" rtlCol="0" anchor="ctr"/>
-          <a:lstStyle/>
-          <a:p>
-            <a:pPr indent="0" marL="0">
-              <a:buNone/>
-            </a:pPr>
-            <a:r>
-              <a:rPr lang="en-US" sz="1300" b="1" dirty="0">
+            <a:off x="6858000" y="2697480"/>
+            <a:ext cx="4663440" cy="576072"/>
+          </a:xfrm>
+          <a:prstGeom prst="rect">
+            <a:avLst/>
+          </a:prstGeom>
+          <a:noFill/>
+          <a:ln/>
+        </p:spPr>
+        <p:txBody>
+          <a:bodyPr wrap="square" lIns="0" tIns="0" rIns="0" bIns="0" rtlCol="0" anchor="ctr"/>
+          <a:lstStyle/>
+          <a:p>
+            <a:pPr indent="0" marL="0">
+              <a:buNone/>
+            </a:pPr>
+            <a:r>
+              <a:rPr lang="en-US" sz="1250" b="1" dirty="0">
                 <a:solidFill>
                   <a:srgbClr val="1F8A4C"/>
                 </a:solidFill>
@@ -4344,7 +4344,7 @@
               <a:buNone/>
             </a:pPr>
             <a:r>
-              <a:rPr lang="en-US" sz="1300" dirty="0">
+              <a:rPr lang="en-US" sz="1250" dirty="0">
                 <a:solidFill>
                   <a:srgbClr val="5A6474"/>
                 </a:solidFill>
@@ -4354,7 +4354,7 @@
               </a:rPr>
               <a:t>· xuất hiện lần 2</a:t>
             </a:r>
-            <a:endParaRPr lang="en-US" sz="1300" dirty="0"/>
+            <a:endParaRPr lang="en-US" sz="1250" dirty="0"/>
           </a:p>
         </p:txBody>
       </p:sp>
@@ -4366,12 +4366,12 @@
         </p:nvSpPr>
         <p:spPr>
           <a:xfrm>
-            <a:off x="548640" y="3831336"/>
-            <a:ext cx="5943600" cy="713232"/>
+            <a:off x="548640" y="3383280"/>
+            <a:ext cx="5943600" cy="576072"/>
           </a:xfrm>
           <a:prstGeom prst="roundRect">
             <a:avLst>
-              <a:gd name="adj" fmla="val 11538"/>
+              <a:gd name="adj" fmla="val 14286"/>
             </a:avLst>
           </a:prstGeom>
           <a:solidFill>
@@ -4400,24 +4400,24 @@
         </p:nvSpPr>
         <p:spPr>
           <a:xfrm>
-            <a:off x="731520" y="3831336"/>
-            <a:ext cx="5669280" cy="713232"/>
-          </a:xfrm>
-          <a:prstGeom prst="rect">
-            <a:avLst/>
-          </a:prstGeom>
-          <a:noFill/>
-          <a:ln/>
-        </p:spPr>
-        <p:txBody>
-          <a:bodyPr wrap="square" lIns="0" tIns="0" rIns="0" bIns="0" rtlCol="0" anchor="ctr"/>
-          <a:lstStyle/>
-          <a:p>
-            <a:pPr indent="0" marL="0">
-              <a:buNone/>
-            </a:pPr>
-            <a:r>
-              <a:rPr lang="en-US" sz="1250" dirty="0">
+            <a:off x="731520" y="3383280"/>
+            <a:ext cx="5669280" cy="576072"/>
+          </a:xfrm>
+          <a:prstGeom prst="rect">
+            <a:avLst/>
+          </a:prstGeom>
+          <a:noFill/>
+          <a:ln/>
+        </p:spPr>
+        <p:txBody>
+          <a:bodyPr wrap="square" lIns="0" tIns="0" rIns="0" bIns="0" rtlCol="0" anchor="ctr"/>
+          <a:lstStyle/>
+          <a:p>
+            <a:pPr indent="0" marL="0">
+              <a:buNone/>
+            </a:pPr>
+            <a:r>
+              <a:rPr lang="en-US" sz="1200" dirty="0">
                 <a:solidFill>
                   <a:srgbClr val="172033"/>
                 </a:solidFill>
@@ -4425,9 +4425,9 @@
                 <a:ea typeface="Consolas" pitchFamily="34" charset="-122"/>
                 <a:cs typeface="Consolas" pitchFamily="34" charset="-120"/>
               </a:rPr>
-              <a:t>ERROR: disk full 98% on db-02</a:t>
-            </a:r>
-            <a:endParaRPr lang="en-US" sz="1250" dirty="0"/>
+              <a:t>ERROR: disk full 98% trên db-02</a:t>
+            </a:r>
+            <a:endParaRPr lang="en-US" sz="1200" dirty="0"/>
           </a:p>
         </p:txBody>
       </p:sp>
@@ -4439,12 +4439,12 @@
         </p:nvSpPr>
         <p:spPr>
           <a:xfrm>
-            <a:off x="6675120" y="3831336"/>
-            <a:ext cx="4983480" cy="713232"/>
+            <a:off x="6675120" y="3383280"/>
+            <a:ext cx="4983480" cy="576072"/>
           </a:xfrm>
           <a:prstGeom prst="roundRect">
             <a:avLst>
-              <a:gd name="adj" fmla="val 10256"/>
+              <a:gd name="adj" fmla="val 12698"/>
             </a:avLst>
           </a:prstGeom>
           <a:solidFill>
@@ -4466,24 +4466,24 @@
         </p:nvSpPr>
         <p:spPr>
           <a:xfrm>
-            <a:off x="6858000" y="3831336"/>
-            <a:ext cx="4663440" cy="713232"/>
-          </a:xfrm>
-          <a:prstGeom prst="rect">
-            <a:avLst/>
-          </a:prstGeom>
-          <a:noFill/>
-          <a:ln/>
-        </p:spPr>
-        <p:txBody>
-          <a:bodyPr wrap="square" lIns="0" tIns="0" rIns="0" bIns="0" rtlCol="0" anchor="ctr"/>
-          <a:lstStyle/>
-          <a:p>
-            <a:pPr indent="0" marL="0">
-              <a:buNone/>
-            </a:pPr>
-            <a:r>
-              <a:rPr lang="en-US" sz="1300" b="1" dirty="0">
+            <a:off x="6858000" y="3383280"/>
+            <a:ext cx="4663440" cy="576072"/>
+          </a:xfrm>
+          <a:prstGeom prst="rect">
+            <a:avLst/>
+          </a:prstGeom>
+          <a:noFill/>
+          <a:ln/>
+        </p:spPr>
+        <p:txBody>
+          <a:bodyPr wrap="square" lIns="0" tIns="0" rIns="0" bIns="0" rtlCol="0" anchor="ctr"/>
+          <a:lstStyle/>
+          <a:p>
+            <a:pPr indent="0" marL="0">
+              <a:buNone/>
+            </a:pPr>
+            <a:r>
+              <a:rPr lang="en-US" sz="1250" b="1" dirty="0">
                 <a:solidFill>
                   <a:srgbClr val="B06E00"/>
                 </a:solidFill>
@@ -4497,7 +4497,7 @@
               <a:buNone/>
             </a:pPr>
             <a:r>
-              <a:rPr lang="en-US" sz="1300" dirty="0">
+              <a:rPr lang="en-US" sz="1250" dirty="0">
                 <a:solidFill>
                   <a:srgbClr val="5A6474"/>
                 </a:solidFill>
@@ -4507,7 +4507,7 @@
               </a:rPr>
               <a:t>· xuất hiện lần 1</a:t>
             </a:r>
-            <a:endParaRPr lang="en-US" sz="1300" dirty="0"/>
+            <a:endParaRPr lang="en-US" sz="1250" dirty="0"/>
           </a:p>
         </p:txBody>
       </p:sp>
@@ -4519,12 +4519,12 @@
         </p:nvSpPr>
         <p:spPr>
           <a:xfrm>
-            <a:off x="548640" y="4672584"/>
-            <a:ext cx="5943600" cy="713232"/>
+            <a:off x="548640" y="4069080"/>
+            <a:ext cx="5943600" cy="576072"/>
           </a:xfrm>
           <a:prstGeom prst="roundRect">
             <a:avLst>
-              <a:gd name="adj" fmla="val 11538"/>
+              <a:gd name="adj" fmla="val 14286"/>
             </a:avLst>
           </a:prstGeom>
           <a:solidFill>
@@ -4553,24 +4553,24 @@
         </p:nvSpPr>
         <p:spPr>
           <a:xfrm>
-            <a:off x="731520" y="4672584"/>
-            <a:ext cx="5669280" cy="713232"/>
-          </a:xfrm>
-          <a:prstGeom prst="rect">
-            <a:avLst/>
-          </a:prstGeom>
-          <a:noFill/>
-          <a:ln/>
-        </p:spPr>
-        <p:txBody>
-          <a:bodyPr wrap="square" lIns="0" tIns="0" rIns="0" bIns="0" rtlCol="0" anchor="ctr"/>
-          <a:lstStyle/>
-          <a:p>
-            <a:pPr indent="0" marL="0">
-              <a:buNone/>
-            </a:pPr>
-            <a:r>
-              <a:rPr lang="en-US" sz="1250" dirty="0">
+            <a:off x="731520" y="4069080"/>
+            <a:ext cx="5669280" cy="576072"/>
+          </a:xfrm>
+          <a:prstGeom prst="rect">
+            <a:avLst/>
+          </a:prstGeom>
+          <a:noFill/>
+          <a:ln/>
+        </p:spPr>
+        <p:txBody>
+          <a:bodyPr wrap="square" lIns="0" tIns="0" rIns="0" bIns="0" rtlCol="0" anchor="ctr"/>
+          <a:lstStyle/>
+          <a:p>
+            <a:pPr indent="0" marL="0">
+              <a:buNone/>
+            </a:pPr>
+            <a:r>
+              <a:rPr lang="en-US" sz="1200" dirty="0">
                 <a:solidFill>
                   <a:srgbClr val="172033"/>
                 </a:solidFill>
@@ -4580,7 +4580,7 @@
               </a:rPr>
               <a:t>Payment declined #77123 — chargeback</a:t>
             </a:r>
-            <a:endParaRPr lang="en-US" sz="1250" dirty="0"/>
+            <a:endParaRPr lang="en-US" sz="1200" dirty="0"/>
           </a:p>
         </p:txBody>
       </p:sp>
@@ -4592,12 +4592,12 @@
         </p:nvSpPr>
         <p:spPr>
           <a:xfrm>
-            <a:off x="6675120" y="4672584"/>
-            <a:ext cx="4983480" cy="713232"/>
+            <a:off x="6675120" y="4069080"/>
+            <a:ext cx="4983480" cy="576072"/>
           </a:xfrm>
           <a:prstGeom prst="roundRect">
             <a:avLst>
-              <a:gd name="adj" fmla="val 10256"/>
+              <a:gd name="adj" fmla="val 12698"/>
             </a:avLst>
           </a:prstGeom>
           <a:solidFill>
@@ -4619,24 +4619,24 @@
         </p:nvSpPr>
         <p:spPr>
           <a:xfrm>
-            <a:off x="6858000" y="4672584"/>
-            <a:ext cx="4663440" cy="713232"/>
-          </a:xfrm>
-          <a:prstGeom prst="rect">
-            <a:avLst/>
-          </a:prstGeom>
-          <a:noFill/>
-          <a:ln/>
-        </p:spPr>
-        <p:txBody>
-          <a:bodyPr wrap="square" lIns="0" tIns="0" rIns="0" bIns="0" rtlCol="0" anchor="ctr"/>
-          <a:lstStyle/>
-          <a:p>
-            <a:pPr indent="0" marL="0">
-              <a:buNone/>
-            </a:pPr>
-            <a:r>
-              <a:rPr lang="en-US" sz="1300" b="1" dirty="0">
+            <a:off x="6858000" y="4069080"/>
+            <a:ext cx="4663440" cy="576072"/>
+          </a:xfrm>
+          <a:prstGeom prst="rect">
+            <a:avLst/>
+          </a:prstGeom>
+          <a:noFill/>
+          <a:ln/>
+        </p:spPr>
+        <p:txBody>
+          <a:bodyPr wrap="square" lIns="0" tIns="0" rIns="0" bIns="0" rtlCol="0" anchor="ctr"/>
+          <a:lstStyle/>
+          <a:p>
+            <a:pPr indent="0" marL="0">
+              <a:buNone/>
+            </a:pPr>
+            <a:r>
+              <a:rPr lang="en-US" sz="1250" b="1" dirty="0">
                 <a:solidFill>
                   <a:srgbClr val="1F8A4C"/>
                 </a:solidFill>
@@ -4650,7 +4650,7 @@
               <a:buNone/>
             </a:pPr>
             <a:r>
-              <a:rPr lang="en-US" sz="1300" dirty="0">
+              <a:rPr lang="en-US" sz="1250" dirty="0">
                 <a:solidFill>
                   <a:srgbClr val="5A6474"/>
                 </a:solidFill>
@@ -4660,13 +4660,166 @@
               </a:rPr>
               <a:t>· xuất hiện lần 3</a:t>
             </a:r>
-            <a:endParaRPr lang="en-US" sz="1300" dirty="0"/>
+            <a:endParaRPr lang="en-US" sz="1250" dirty="0"/>
           </a:p>
         </p:txBody>
       </p:sp>
       <p:sp>
         <p:nvSpPr>
           <p:cNvPr id="22" name="Shape 20"/>
+          <p:cNvSpPr/>
+          <p:nvPr/>
+        </p:nvSpPr>
+        <p:spPr>
+          <a:xfrm>
+            <a:off x="548640" y="4754880"/>
+            <a:ext cx="5943600" cy="576072"/>
+          </a:xfrm>
+          <a:prstGeom prst="roundRect">
+            <a:avLst>
+              <a:gd name="adj" fmla="val 14286"/>
+            </a:avLst>
+          </a:prstGeom>
+          <a:solidFill>
+            <a:srgbClr val="FFFFFF"/>
+          </a:solidFill>
+          <a:ln w="12700">
+            <a:solidFill>
+              <a:srgbClr val="D9DFE7"/>
+            </a:solidFill>
+            <a:prstDash val="solid"/>
+          </a:ln>
+          <a:effectLst>
+            <a:outerShdw sx="100000" sy="100000" kx="0" ky="0" algn="bl" rotWithShape="0" blurRad="88900" dist="38100" dir="5400000">
+              <a:srgbClr val="000000">
+                <a:alpha val="13000"/>
+              </a:srgbClr>
+            </a:outerShdw>
+          </a:effectLst>
+        </p:spPr>
+      </p:sp>
+      <p:sp>
+        <p:nvSpPr>
+          <p:cNvPr id="23" name="Text 21"/>
+          <p:cNvSpPr/>
+          <p:nvPr/>
+        </p:nvSpPr>
+        <p:spPr>
+          <a:xfrm>
+            <a:off x="731520" y="4754880"/>
+            <a:ext cx="5669280" cy="576072"/>
+          </a:xfrm>
+          <a:prstGeom prst="rect">
+            <a:avLst/>
+          </a:prstGeom>
+          <a:noFill/>
+          <a:ln/>
+        </p:spPr>
+        <p:txBody>
+          <a:bodyPr wrap="square" lIns="0" tIns="0" rIns="0" bIns="0" rtlCol="0" anchor="ctr"/>
+          <a:lstStyle/>
+          <a:p>
+            <a:pPr indent="0" marL="0">
+              <a:buNone/>
+            </a:pPr>
+            <a:r>
+              <a:rPr lang="en-US" sz="1200" dirty="0">
+                <a:solidFill>
+                  <a:srgbClr val="172033"/>
+                </a:solidFill>
+                <a:latin typeface="Consolas" pitchFamily="34" charset="0"/>
+                <a:ea typeface="Consolas" pitchFamily="34" charset="-122"/>
+                <a:cs typeface="Consolas" pitchFamily="34" charset="-120"/>
+              </a:rPr>
+              <a:t>Kafka broker CRITICAL unavailable</a:t>
+            </a:r>
+            <a:endParaRPr lang="en-US" sz="1200" dirty="0"/>
+          </a:p>
+        </p:txBody>
+      </p:sp>
+      <p:sp>
+        <p:nvSpPr>
+          <p:cNvPr id="24" name="Shape 22"/>
+          <p:cNvSpPr/>
+          <p:nvPr/>
+        </p:nvSpPr>
+        <p:spPr>
+          <a:xfrm>
+            <a:off x="6675120" y="4754880"/>
+            <a:ext cx="4983480" cy="576072"/>
+          </a:xfrm>
+          <a:prstGeom prst="roundRect">
+            <a:avLst>
+              <a:gd name="adj" fmla="val 12698"/>
+            </a:avLst>
+          </a:prstGeom>
+          <a:solidFill>
+            <a:srgbClr val="FFF3D6"/>
+          </a:solidFill>
+          <a:ln w="15240">
+            <a:solidFill>
+              <a:srgbClr val="B06E00"/>
+            </a:solidFill>
+            <a:prstDash val="solid"/>
+          </a:ln>
+        </p:spPr>
+      </p:sp>
+      <p:sp>
+        <p:nvSpPr>
+          <p:cNvPr id="25" name="Text 23"/>
+          <p:cNvSpPr/>
+          <p:nvPr/>
+        </p:nvSpPr>
+        <p:spPr>
+          <a:xfrm>
+            <a:off x="6858000" y="4754880"/>
+            <a:ext cx="4663440" cy="576072"/>
+          </a:xfrm>
+          <a:prstGeom prst="rect">
+            <a:avLst/>
+          </a:prstGeom>
+          <a:noFill/>
+          <a:ln/>
+        </p:spPr>
+        <p:txBody>
+          <a:bodyPr wrap="square" lIns="0" tIns="0" rIns="0" bIns="0" rtlCol="0" anchor="ctr"/>
+          <a:lstStyle/>
+          <a:p>
+            <a:pPr indent="0" marL="0">
+              <a:buNone/>
+            </a:pPr>
+            <a:r>
+              <a:rPr lang="en-US" sz="1250" b="1" dirty="0">
+                <a:solidFill>
+                  <a:srgbClr val="B06E00"/>
+                </a:solidFill>
+                <a:latin typeface="Calibri" pitchFamily="34" charset="0"/>
+                <a:ea typeface="Calibri" pitchFamily="34" charset="-122"/>
+                <a:cs typeface="Calibri" pitchFamily="34" charset="-120"/>
+              </a:rPr>
+              <a:t>🆕 SỰ CỐ MỚI   </a:t>
+            </a:r>
+            <a:pPr indent="0" marL="0">
+              <a:buNone/>
+            </a:pPr>
+            <a:r>
+              <a:rPr lang="en-US" sz="1250" dirty="0">
+                <a:solidFill>
+                  <a:srgbClr val="5A6474"/>
+                </a:solidFill>
+                <a:latin typeface="Calibri" pitchFamily="34" charset="0"/>
+                <a:ea typeface="Calibri" pitchFamily="34" charset="-122"/>
+                <a:cs typeface="Calibri" pitchFamily="34" charset="-120"/>
+              </a:rPr>
+              <a:t>· xuất hiện lần 1</a:t>
+            </a:r>
+            <a:endParaRPr lang="en-US" sz="1250" dirty="0"/>
+          </a:p>
+        </p:txBody>
+      </p:sp>
+      <p:sp>
+        <p:nvSpPr>
+          <p:cNvPr id="26" name="Shape 24"/>
           <p:cNvSpPr/>
           <p:nvPr/>
         </p:nvSpPr>
@@ -4688,7 +4841,7 @@
       </p:sp>
       <p:sp>
         <p:nvSpPr>
-          <p:cNvPr id="23" name="Text 21"/>
+          <p:cNvPr id="27" name="Text 25"/>
           <p:cNvSpPr/>
           <p:nvPr/>
         </p:nvSpPr>
@@ -4733,7 +4886,7 @@
                 <a:ea typeface="Calibri" pitchFamily="34" charset="-122"/>
                 <a:cs typeface="Calibri" pitchFamily="34" charset="-120"/>
               </a:rPr>
-              <a:t>4 cảnh báo → chỉ 2 sự cố thật sự khác nhau. Người trực không bị spam 4 lần cho cùng 1 vấn đề. </a:t>
+              <a:t>5 cảnh báo → chỉ 3 sự cố thật sự khác nhau. Người trực không bị spam nhiều lần cho cùng 1 vấn đề. </a:t>
             </a:r>
             <a:pPr indent="0" marL="0">
               <a:buNone/>
@@ -6252,7 +6405,7 @@
       </p:sp>
       <p:pic>
         <p:nvPicPr>
-          <p:cNvPr id="6" name="Image 0" descr="D:/AI/screen-watcher-pro/workshop/evidence/tts_waveform.png">    </p:cNvPr>
+          <p:cNvPr id="6" name="Image 0" descr="D:/AI/screen-watcher-pro/workshop/110726/evidence/tts_waveform.png">    </p:cNvPr>
           <p:cNvPicPr>
             <a:picLocks noChangeAspect="1"/>
           </p:cNvPicPr>
@@ -6346,7 +6499,7 @@
                 <a:ea typeface="Calibri" pitchFamily="34" charset="-122"/>
                 <a:cs typeface="Calibri" pitchFamily="34" charset="-120"/>
               </a:rPr>
-              <a:t>"Cảnh báo nghiêm trọng. Hệ thống thanh toán phát hiện giao dịch gian lận. Vui lòng kiểm tra ngay."</a:t>
+              <a:t>"Cảnh báo. Sự cố nghiêm trọng vừa được xác nhận. Vui lòng kiểm tra hệ thống ngay lập tức."</a:t>
             </a:r>
             <a:endParaRPr lang="en-US" sz="1250" dirty="0"/>
           </a:p>
@@ -6502,7 +6655,7 @@
                 <a:ea typeface="Calibri" pitchFamily="34" charset="-122"/>
                 <a:cs typeface="Calibri" pitchFamily="34" charset="-120"/>
               </a:rPr>
-              <a:t>5.86 giây · 16.000 Hz · mono · dựng trên CPU (không GPU)</a:t>
+              <a:t>5.95 giây · 16.000 Hz · mono · dựng trên CPU (không GPU)</a:t>
             </a:r>
             <a:endParaRPr lang="en-US" sz="1250" dirty="0"/>
           </a:p>
@@ -6619,7 +6772,7 @@
                 <a:ea typeface="Consolas" pitchFamily="34" charset="-122"/>
                 <a:cs typeface="Consolas" pitchFamily="34" charset="-120"/>
               </a:rPr>
-              <a:t>File: workshop/evidence/tts_alert_vi.wav  ·  tts_mms_vie_sample.wav  ·  7/7 test tự động PASS</a:t>
+              <a:t>File: workshop/110726/evidence/tts_alert_vi.wav  ·  8/8 test tự động PASS (bao gồm cả synth thật)</a:t>
             </a:r>
             <a:endParaRPr lang="en-US" sz="1050" dirty="0"/>
           </a:p>

</xml_diff>